<commit_message>
Update deck for the closed loop
Slide 6 still described a flow that ended at a recommendation. Step three is now
the loop itself, and the results slide carries the end-to-end proof, since a
page that visibly moves the network is the answer to the 25% criterion.

Co-Authored-By: Claude Opus 5 <noreply@anthropic.com>
</commit_message>
<xml_diff>
--- a/pitch/MedMesh-TwoClocks.pptx
+++ b/pitch/MedMesh-TwoClocks.pptx
@@ -7280,7 +7280,7 @@
                 <a:ea typeface="Calibri" pitchFamily="34" charset="-122"/>
                 <a:cs typeface="Calibri" pitchFamily="34" charset="-120"/>
               </a:rPr>
-              <a:t>Propose the move, and the reason</a:t>
+              <a:t>Move it, and say why</a:t>
             </a:r>
             <a:endParaRPr lang="en-US" sz="1500" dirty="0"/>
           </a:p>
@@ -7322,7 +7322,7 @@
                 <a:ea typeface="Calibri" pitchFamily="34" charset="-122"/>
                 <a:cs typeface="Calibri" pitchFamily="34" charset="-120"/>
               </a:rPr>
-              <a:t>Surplus matched to shortage on distance, urgency and remaining shelf life, then written up as one sentence an officer can approve. Nothing executes on its own.</a:t>
+              <a:t>A committed count re-runs both clocks and re-runs the matcher across the district. One photographed page moved 13 medicines between states and created 11 transfers that did not exist a moment before. Gemini writes the justification; a human approves.</a:t>
             </a:r>
             <a:endParaRPr lang="en-US" sz="1150" dirty="0"/>
           </a:p>
@@ -7361,7 +7361,7 @@
                 <a:ea typeface="Calibri" pitchFamily="34" charset="-122"/>
                 <a:cs typeface="Calibri" pitchFamily="34" charset="-120"/>
               </a:rPr>
-              <a:t>A human always approves</a:t>
+              <a:t>Paper to transfer, one request</a:t>
             </a:r>
             <a:endParaRPr lang="en-US" sz="1100" dirty="0"/>
           </a:p>
@@ -9002,8 +9002,8 @@
         </p:nvSpPr>
         <p:spPr>
           <a:xfrm>
-            <a:off x="640080" y="5413248"/>
-            <a:ext cx="10908792" cy="457200"/>
+            <a:off x="640080" y="5376672"/>
+            <a:ext cx="10908792" cy="566928"/>
           </a:xfrm>
           <a:prstGeom prst="rect">
             <a:avLst/>
@@ -9027,7 +9027,7 @@
                 <a:ea typeface="Calibri" pitchFamily="34" charset="-122"/>
                 <a:cs typeface="Calibri" pitchFamily="34" charset="-120"/>
               </a:rPr>
-              <a:t>Waste averted counts only units the projection says would have expired unused. Stock merely moved somewhere more useful is not counted, which makes the number smaller and defensible.</a:t>
+              <a:t>End to end, live: photographing one register page moves 13 medicines between states and creates 11 transfers that did not exist seconds earlier. Waste averted counts only units that would genuinely have expired, keeping the number smaller and defensible.</a:t>
             </a:r>
             <a:endParaRPr lang="en-US" sz="1150" dirty="0"/>
           </a:p>

</xml_diff>